<commit_message>
feat: embed 4 architecture diagrams into PowerPoint (Agent Skills, MCP, Fabric IQ, Agentic Stack)
</commit_message>
<xml_diff>
--- a/agentic-ai-for-power-bi/agentic-ai-presentation.pptx
+++ b/agentic-ai-for-power-bi/agentic-ai-presentation.pptx
@@ -4984,9 +4984,33 @@
           </a:p>
         </p:txBody>
       </p:sp>
-      <p:sp>
-        <p:nvSpPr>
-          <p:cNvPr id="24" name="TextBox 23"/>
+      <p:pic>
+        <p:nvPicPr>
+          <p:cNvPr id="24" name="Picture 23" descr="agentic_stack_diagram.png"/>
+          <p:cNvPicPr>
+            <a:picLocks noChangeAspect="1"/>
+          </p:cNvPicPr>
+          <p:nvPr/>
+        </p:nvPicPr>
+        <p:blipFill>
+          <a:blip r:embed="rId2"/>
+          <a:stretch>
+            <a:fillRect/>
+          </a:stretch>
+        </p:blipFill>
+        <p:spPr>
+          <a:xfrm>
+            <a:off x="365760" y="5349240"/>
+            <a:ext cx="11430000" cy="1325880"/>
+          </a:xfrm>
+          <a:prstGeom prst="rect">
+            <a:avLst/>
+          </a:prstGeom>
+        </p:spPr>
+      </p:pic>
+      <p:sp>
+        <p:nvSpPr>
+          <p:cNvPr id="25" name="TextBox 24"/>
           <p:cNvSpPr txBox="1"/>
           <p:nvPr/>
         </p:nvSpPr>
@@ -5021,7 +5045,7 @@
       </p:sp>
       <p:sp>
         <p:nvSpPr>
-          <p:cNvPr id="25" name="TextBox 24"/>
+          <p:cNvPr id="26" name="TextBox 25"/>
           <p:cNvSpPr txBox="1"/>
           <p:nvPr/>
         </p:nvSpPr>
@@ -7097,9 +7121,33 @@
           </a:p>
         </p:txBody>
       </p:sp>
-      <p:sp>
-        <p:nvSpPr>
-          <p:cNvPr id="27" name="TextBox 26"/>
+      <p:pic>
+        <p:nvPicPr>
+          <p:cNvPr id="27" name="Picture 26" descr="agent_skills_workflow.png"/>
+          <p:cNvPicPr>
+            <a:picLocks noChangeAspect="1"/>
+          </p:cNvPicPr>
+          <p:nvPr/>
+        </p:nvPicPr>
+        <p:blipFill>
+          <a:blip r:embed="rId2"/>
+          <a:stretch>
+            <a:fillRect/>
+          </a:stretch>
+        </p:blipFill>
+        <p:spPr>
+          <a:xfrm>
+            <a:off x="365760" y="1261872"/>
+            <a:ext cx="11430000" cy="4023360"/>
+          </a:xfrm>
+          <a:prstGeom prst="rect">
+            <a:avLst/>
+          </a:prstGeom>
+        </p:spPr>
+      </p:pic>
+      <p:sp>
+        <p:nvSpPr>
+          <p:cNvPr id="28" name="TextBox 27"/>
           <p:cNvSpPr txBox="1"/>
           <p:nvPr/>
         </p:nvSpPr>
@@ -7134,7 +7182,7 @@
       </p:sp>
       <p:sp>
         <p:nvSpPr>
-          <p:cNvPr id="28" name="TextBox 27"/>
+          <p:cNvPr id="29" name="TextBox 28"/>
           <p:cNvSpPr txBox="1"/>
           <p:nvPr/>
         </p:nvSpPr>
@@ -8591,9 +8639,33 @@
           </a:p>
         </p:txBody>
       </p:sp>
-      <p:sp>
-        <p:nvSpPr>
-          <p:cNvPr id="17" name="TextBox 16"/>
+      <p:pic>
+        <p:nvPicPr>
+          <p:cNvPr id="17" name="Picture 16" descr="mcp_architecture_diagram.png"/>
+          <p:cNvPicPr>
+            <a:picLocks noChangeAspect="1"/>
+          </p:cNvPicPr>
+          <p:nvPr/>
+        </p:nvPicPr>
+        <p:blipFill>
+          <a:blip r:embed="rId2"/>
+          <a:stretch>
+            <a:fillRect/>
+          </a:stretch>
+        </p:blipFill>
+        <p:spPr>
+          <a:xfrm>
+            <a:off x="365760" y="1261872"/>
+            <a:ext cx="11430000" cy="4572000"/>
+          </a:xfrm>
+          <a:prstGeom prst="rect">
+            <a:avLst/>
+          </a:prstGeom>
+        </p:spPr>
+      </p:pic>
+      <p:sp>
+        <p:nvSpPr>
+          <p:cNvPr id="18" name="TextBox 17"/>
           <p:cNvSpPr txBox="1"/>
           <p:nvPr/>
         </p:nvSpPr>
@@ -8628,7 +8700,7 @@
       </p:sp>
       <p:sp>
         <p:nvSpPr>
-          <p:cNvPr id="18" name="TextBox 17"/>
+          <p:cNvPr id="19" name="TextBox 18"/>
           <p:cNvSpPr txBox="1"/>
           <p:nvPr/>
         </p:nvSpPr>
@@ -9440,9 +9512,33 @@
           </a:p>
         </p:txBody>
       </p:sp>
-      <p:sp>
-        <p:nvSpPr>
-          <p:cNvPr id="21" name="TextBox 20"/>
+      <p:pic>
+        <p:nvPicPr>
+          <p:cNvPr id="21" name="Picture 20" descr="fabric_iq_ecosystem.png"/>
+          <p:cNvPicPr>
+            <a:picLocks noChangeAspect="1"/>
+          </p:cNvPicPr>
+          <p:nvPr/>
+        </p:nvPicPr>
+        <p:blipFill>
+          <a:blip r:embed="rId2"/>
+          <a:stretch>
+            <a:fillRect/>
+          </a:stretch>
+        </p:blipFill>
+        <p:spPr>
+          <a:xfrm>
+            <a:off x="365760" y="1261872"/>
+            <a:ext cx="11430000" cy="4572000"/>
+          </a:xfrm>
+          <a:prstGeom prst="rect">
+            <a:avLst/>
+          </a:prstGeom>
+        </p:spPr>
+      </p:pic>
+      <p:sp>
+        <p:nvSpPr>
+          <p:cNvPr id="22" name="TextBox 21"/>
           <p:cNvSpPr txBox="1"/>
           <p:nvPr/>
         </p:nvSpPr>
@@ -9477,7 +9573,7 @@
       </p:sp>
       <p:sp>
         <p:nvSpPr>
-          <p:cNvPr id="22" name="TextBox 21"/>
+          <p:cNvPr id="23" name="TextBox 22"/>
           <p:cNvSpPr txBox="1"/>
           <p:nvPr/>
         </p:nvSpPr>

</xml_diff>

<commit_message>
chore: clean up legacy remotion folder and update presentation scripts
</commit_message>
<xml_diff>
--- a/agentic-ai-for-power-bi/agentic-ai-presentation.pptx
+++ b/agentic-ai-for-power-bi/agentic-ai-presentation.pptx
@@ -5,18 +5,18 @@
     <p:sldMasterId id="2147483648" r:id="rId1"/>
   </p:sldMasterIdLst>
   <p:sldIdLst>
-    <p:sldId id="256" r:id="rId7"/>
-    <p:sldId id="257" r:id="rId8"/>
-    <p:sldId id="258" r:id="rId9"/>
-    <p:sldId id="259" r:id="rId10"/>
-    <p:sldId id="260" r:id="rId11"/>
-    <p:sldId id="261" r:id="rId12"/>
-    <p:sldId id="262" r:id="rId13"/>
-    <p:sldId id="263" r:id="rId14"/>
-    <p:sldId id="264" r:id="rId15"/>
-    <p:sldId id="265" r:id="rId16"/>
+    <p:sldId id="256" r:id="rId2"/>
+    <p:sldId id="257" r:id="rId3"/>
+    <p:sldId id="258" r:id="rId4"/>
+    <p:sldId id="259" r:id="rId5"/>
+    <p:sldId id="260" r:id="rId6"/>
+    <p:sldId id="261" r:id="rId7"/>
+    <p:sldId id="262" r:id="rId8"/>
+    <p:sldId id="263" r:id="rId9"/>
+    <p:sldId id="264" r:id="rId10"/>
+    <p:sldId id="265" r:id="rId11"/>
   </p:sldIdLst>
-  <p:sldSz cx="12188952" cy="6858000" type="screen4x3"/>
+  <p:sldSz cx="12188825" cy="6858000"/>
   <p:notesSz cx="6858000" cy="9144000"/>
   <p:defaultTextStyle>
     <a:defPPr>
@@ -113,6 +113,22 @@
       </a:defRPr>
     </a:lvl9pPr>
   </p:defaultTextStyle>
+  <p:extLst>
+    <p:ext uri="{EFAFB233-063F-42B5-8137-9DF3F51BA10A}">
+      <p15:sldGuideLst xmlns:p15="http://schemas.microsoft.com/office/powerpoint/2012/main">
+        <p15:guide id="1" orient="horz" pos="2160">
+          <p15:clr>
+            <a:srgbClr val="A4A3A4"/>
+          </p15:clr>
+        </p15:guide>
+        <p15:guide id="2" pos="2880">
+          <p15:clr>
+            <a:srgbClr val="A4A3A4"/>
+          </p15:clr>
+        </p15:guide>
+      </p15:sldGuideLst>
+    </p:ext>
+  </p:extLst>
 </p:presentation>
 </file>
 
@@ -154,10 +170,9 @@
           <a:lstStyle/>
           <a:p>
             <a:r>
-              <a:rPr lang="en-US" smtClean="0"/>
+              <a:rPr lang="en-US"/>
               <a:t>Click to edit Master title style</a:t>
             </a:r>
-            <a:endParaRPr lang="en-US"/>
           </a:p>
         </p:txBody>
       </p:sp>
@@ -273,10 +288,9 @@
           </a:lstStyle>
           <a:p>
             <a:r>
-              <a:rPr lang="en-US" smtClean="0"/>
+              <a:rPr lang="en-US"/>
               <a:t>Click to edit Master subtitle style</a:t>
             </a:r>
-            <a:endParaRPr lang="en-US"/>
           </a:p>
         </p:txBody>
       </p:sp>
@@ -297,7 +311,7 @@
           <a:p>
             <a:fld id="{5BCAD085-E8A6-8845-BD4E-CB4CCA059FC4}" type="datetimeFigureOut">
               <a:rPr lang="en-US" smtClean="0"/>
-              <a:t>1/27/13</a:t>
+              <a:t>8/11/2026</a:t>
             </a:fld>
             <a:endParaRPr lang="en-US"/>
           </a:p>
@@ -391,10 +405,9 @@
           <a:lstStyle/>
           <a:p>
             <a:r>
-              <a:rPr lang="en-US" smtClean="0"/>
+              <a:rPr lang="en-US"/>
               <a:t>Click to edit Master title style</a:t>
             </a:r>
-            <a:endParaRPr lang="en-US"/>
           </a:p>
         </p:txBody>
       </p:sp>
@@ -415,38 +428,37 @@
           <a:p>
             <a:pPr lvl="0"/>
             <a:r>
-              <a:rPr lang="en-US" smtClean="0"/>
+              <a:rPr lang="en-US"/>
               <a:t>Click to edit Master text styles</a:t>
             </a:r>
           </a:p>
           <a:p>
             <a:pPr lvl="1"/>
             <a:r>
-              <a:rPr lang="en-US" smtClean="0"/>
+              <a:rPr lang="en-US"/>
               <a:t>Second level</a:t>
             </a:r>
           </a:p>
           <a:p>
             <a:pPr lvl="2"/>
             <a:r>
-              <a:rPr lang="en-US" smtClean="0"/>
+              <a:rPr lang="en-US"/>
               <a:t>Third level</a:t>
             </a:r>
           </a:p>
           <a:p>
             <a:pPr lvl="3"/>
             <a:r>
-              <a:rPr lang="en-US" smtClean="0"/>
+              <a:rPr lang="en-US"/>
               <a:t>Fourth level</a:t>
             </a:r>
           </a:p>
           <a:p>
             <a:pPr lvl="4"/>
             <a:r>
-              <a:rPr lang="en-US" smtClean="0"/>
+              <a:rPr lang="en-US"/>
               <a:t>Fifth level</a:t>
             </a:r>
-            <a:endParaRPr lang="en-US"/>
           </a:p>
         </p:txBody>
       </p:sp>
@@ -467,7 +479,7 @@
           <a:p>
             <a:fld id="{5BCAD085-E8A6-8845-BD4E-CB4CCA059FC4}" type="datetimeFigureOut">
               <a:rPr lang="en-US" smtClean="0"/>
-              <a:t>1/27/13</a:t>
+              <a:t>8/11/2026</a:t>
             </a:fld>
             <a:endParaRPr lang="en-US"/>
           </a:p>
@@ -566,10 +578,9 @@
           <a:lstStyle/>
           <a:p>
             <a:r>
-              <a:rPr lang="en-US" smtClean="0"/>
+              <a:rPr lang="en-US"/>
               <a:t>Click to edit Master title style</a:t>
             </a:r>
-            <a:endParaRPr lang="en-US"/>
           </a:p>
         </p:txBody>
       </p:sp>
@@ -595,38 +606,37 @@
           <a:p>
             <a:pPr lvl="0"/>
             <a:r>
-              <a:rPr lang="en-US" smtClean="0"/>
+              <a:rPr lang="en-US"/>
               <a:t>Click to edit Master text styles</a:t>
             </a:r>
           </a:p>
           <a:p>
             <a:pPr lvl="1"/>
             <a:r>
-              <a:rPr lang="en-US" smtClean="0"/>
+              <a:rPr lang="en-US"/>
               <a:t>Second level</a:t>
             </a:r>
           </a:p>
           <a:p>
             <a:pPr lvl="2"/>
             <a:r>
-              <a:rPr lang="en-US" smtClean="0"/>
+              <a:rPr lang="en-US"/>
               <a:t>Third level</a:t>
             </a:r>
           </a:p>
           <a:p>
             <a:pPr lvl="3"/>
             <a:r>
-              <a:rPr lang="en-US" smtClean="0"/>
+              <a:rPr lang="en-US"/>
               <a:t>Fourth level</a:t>
             </a:r>
           </a:p>
           <a:p>
             <a:pPr lvl="4"/>
             <a:r>
-              <a:rPr lang="en-US" smtClean="0"/>
+              <a:rPr lang="en-US"/>
               <a:t>Fifth level</a:t>
             </a:r>
-            <a:endParaRPr lang="en-US"/>
           </a:p>
         </p:txBody>
       </p:sp>
@@ -647,7 +657,7 @@
           <a:p>
             <a:fld id="{5BCAD085-E8A6-8845-BD4E-CB4CCA059FC4}" type="datetimeFigureOut">
               <a:rPr lang="en-US" smtClean="0"/>
-              <a:t>1/27/13</a:t>
+              <a:t>8/11/2026</a:t>
             </a:fld>
             <a:endParaRPr lang="en-US"/>
           </a:p>
@@ -741,10 +751,9 @@
           <a:lstStyle/>
           <a:p>
             <a:r>
-              <a:rPr lang="en-US" smtClean="0"/>
+              <a:rPr lang="en-US"/>
               <a:t>Click to edit Master title style</a:t>
             </a:r>
-            <a:endParaRPr lang="en-US"/>
           </a:p>
         </p:txBody>
       </p:sp>
@@ -765,38 +774,37 @@
           <a:p>
             <a:pPr lvl="0"/>
             <a:r>
-              <a:rPr lang="en-US" smtClean="0"/>
+              <a:rPr lang="en-US"/>
               <a:t>Click to edit Master text styles</a:t>
             </a:r>
           </a:p>
           <a:p>
             <a:pPr lvl="1"/>
             <a:r>
-              <a:rPr lang="en-US" smtClean="0"/>
+              <a:rPr lang="en-US"/>
               <a:t>Second level</a:t>
             </a:r>
           </a:p>
           <a:p>
             <a:pPr lvl="2"/>
             <a:r>
-              <a:rPr lang="en-US" smtClean="0"/>
+              <a:rPr lang="en-US"/>
               <a:t>Third level</a:t>
             </a:r>
           </a:p>
           <a:p>
             <a:pPr lvl="3"/>
             <a:r>
-              <a:rPr lang="en-US" smtClean="0"/>
+              <a:rPr lang="en-US"/>
               <a:t>Fourth level</a:t>
             </a:r>
           </a:p>
           <a:p>
             <a:pPr lvl="4"/>
             <a:r>
-              <a:rPr lang="en-US" smtClean="0"/>
+              <a:rPr lang="en-US"/>
               <a:t>Fifth level</a:t>
             </a:r>
-            <a:endParaRPr lang="en-US"/>
           </a:p>
         </p:txBody>
       </p:sp>
@@ -817,7 +825,7 @@
           <a:p>
             <a:fld id="{5BCAD085-E8A6-8845-BD4E-CB4CCA059FC4}" type="datetimeFigureOut">
               <a:rPr lang="en-US" smtClean="0"/>
-              <a:t>1/27/13</a:t>
+              <a:t>8/11/2026</a:t>
             </a:fld>
             <a:endParaRPr lang="en-US"/>
           </a:p>
@@ -920,10 +928,9 @@
           </a:lstStyle>
           <a:p>
             <a:r>
-              <a:rPr lang="en-US" smtClean="0"/>
+              <a:rPr lang="en-US"/>
               <a:t>Click to edit Master title style</a:t>
             </a:r>
-            <a:endParaRPr lang="en-US"/>
           </a:p>
         </p:txBody>
       </p:sp>
@@ -1040,7 +1047,7 @@
           <a:p>
             <a:pPr lvl="0"/>
             <a:r>
-              <a:rPr lang="en-US" smtClean="0"/>
+              <a:rPr lang="en-US"/>
               <a:t>Click to edit Master text styles</a:t>
             </a:r>
           </a:p>
@@ -1063,7 +1070,7 @@
           <a:p>
             <a:fld id="{5BCAD085-E8A6-8845-BD4E-CB4CCA059FC4}" type="datetimeFigureOut">
               <a:rPr lang="en-US" smtClean="0"/>
-              <a:t>1/27/13</a:t>
+              <a:t>8/11/2026</a:t>
             </a:fld>
             <a:endParaRPr lang="en-US"/>
           </a:p>
@@ -1157,10 +1164,9 @@
           <a:lstStyle/>
           <a:p>
             <a:r>
-              <a:rPr lang="en-US" smtClean="0"/>
+              <a:rPr lang="en-US"/>
               <a:t>Click to edit Master title style</a:t>
             </a:r>
-            <a:endParaRPr lang="en-US"/>
           </a:p>
         </p:txBody>
       </p:sp>
@@ -1214,38 +1220,37 @@
           <a:p>
             <a:pPr lvl="0"/>
             <a:r>
-              <a:rPr lang="en-US" smtClean="0"/>
+              <a:rPr lang="en-US"/>
               <a:t>Click to edit Master text styles</a:t>
             </a:r>
           </a:p>
           <a:p>
             <a:pPr lvl="1"/>
             <a:r>
-              <a:rPr lang="en-US" smtClean="0"/>
+              <a:rPr lang="en-US"/>
               <a:t>Second level</a:t>
             </a:r>
           </a:p>
           <a:p>
             <a:pPr lvl="2"/>
             <a:r>
-              <a:rPr lang="en-US" smtClean="0"/>
+              <a:rPr lang="en-US"/>
               <a:t>Third level</a:t>
             </a:r>
           </a:p>
           <a:p>
             <a:pPr lvl="3"/>
             <a:r>
-              <a:rPr lang="en-US" smtClean="0"/>
+              <a:rPr lang="en-US"/>
               <a:t>Fourth level</a:t>
             </a:r>
           </a:p>
           <a:p>
             <a:pPr lvl="4"/>
             <a:r>
-              <a:rPr lang="en-US" smtClean="0"/>
+              <a:rPr lang="en-US"/>
               <a:t>Fifth level</a:t>
             </a:r>
-            <a:endParaRPr lang="en-US"/>
           </a:p>
         </p:txBody>
       </p:sp>
@@ -1299,38 +1304,37 @@
           <a:p>
             <a:pPr lvl="0"/>
             <a:r>
-              <a:rPr lang="en-US" smtClean="0"/>
+              <a:rPr lang="en-US"/>
               <a:t>Click to edit Master text styles</a:t>
             </a:r>
           </a:p>
           <a:p>
             <a:pPr lvl="1"/>
             <a:r>
-              <a:rPr lang="en-US" smtClean="0"/>
+              <a:rPr lang="en-US"/>
               <a:t>Second level</a:t>
             </a:r>
           </a:p>
           <a:p>
             <a:pPr lvl="2"/>
             <a:r>
-              <a:rPr lang="en-US" smtClean="0"/>
+              <a:rPr lang="en-US"/>
               <a:t>Third level</a:t>
             </a:r>
           </a:p>
           <a:p>
             <a:pPr lvl="3"/>
             <a:r>
-              <a:rPr lang="en-US" smtClean="0"/>
+              <a:rPr lang="en-US"/>
               <a:t>Fourth level</a:t>
             </a:r>
           </a:p>
           <a:p>
             <a:pPr lvl="4"/>
             <a:r>
-              <a:rPr lang="en-US" smtClean="0"/>
+              <a:rPr lang="en-US"/>
               <a:t>Fifth level</a:t>
             </a:r>
-            <a:endParaRPr lang="en-US"/>
           </a:p>
         </p:txBody>
       </p:sp>
@@ -1351,7 +1355,7 @@
           <a:p>
             <a:fld id="{5BCAD085-E8A6-8845-BD4E-CB4CCA059FC4}" type="datetimeFigureOut">
               <a:rPr lang="en-US" smtClean="0"/>
-              <a:t>1/27/13</a:t>
+              <a:t>8/11/2026</a:t>
             </a:fld>
             <a:endParaRPr lang="en-US"/>
           </a:p>
@@ -1449,10 +1453,9 @@
           </a:lstStyle>
           <a:p>
             <a:r>
-              <a:rPr lang="en-US" smtClean="0"/>
+              <a:rPr lang="en-US"/>
               <a:t>Click to edit Master title style</a:t>
             </a:r>
-            <a:endParaRPr lang="en-US"/>
           </a:p>
         </p:txBody>
       </p:sp>
@@ -1515,7 +1518,7 @@
           <a:p>
             <a:pPr lvl="0"/>
             <a:r>
-              <a:rPr lang="en-US" smtClean="0"/>
+              <a:rPr lang="en-US"/>
               <a:t>Click to edit Master text styles</a:t>
             </a:r>
           </a:p>
@@ -1571,38 +1574,37 @@
           <a:p>
             <a:pPr lvl="0"/>
             <a:r>
-              <a:rPr lang="en-US" smtClean="0"/>
+              <a:rPr lang="en-US"/>
               <a:t>Click to edit Master text styles</a:t>
             </a:r>
           </a:p>
           <a:p>
             <a:pPr lvl="1"/>
             <a:r>
-              <a:rPr lang="en-US" smtClean="0"/>
+              <a:rPr lang="en-US"/>
               <a:t>Second level</a:t>
             </a:r>
           </a:p>
           <a:p>
             <a:pPr lvl="2"/>
             <a:r>
-              <a:rPr lang="en-US" smtClean="0"/>
+              <a:rPr lang="en-US"/>
               <a:t>Third level</a:t>
             </a:r>
           </a:p>
           <a:p>
             <a:pPr lvl="3"/>
             <a:r>
-              <a:rPr lang="en-US" smtClean="0"/>
+              <a:rPr lang="en-US"/>
               <a:t>Fourth level</a:t>
             </a:r>
           </a:p>
           <a:p>
             <a:pPr lvl="4"/>
             <a:r>
-              <a:rPr lang="en-US" smtClean="0"/>
+              <a:rPr lang="en-US"/>
               <a:t>Fifth level</a:t>
             </a:r>
-            <a:endParaRPr lang="en-US"/>
           </a:p>
         </p:txBody>
       </p:sp>
@@ -1665,7 +1667,7 @@
           <a:p>
             <a:pPr lvl="0"/>
             <a:r>
-              <a:rPr lang="en-US" smtClean="0"/>
+              <a:rPr lang="en-US"/>
               <a:t>Click to edit Master text styles</a:t>
             </a:r>
           </a:p>
@@ -1721,38 +1723,37 @@
           <a:p>
             <a:pPr lvl="0"/>
             <a:r>
-              <a:rPr lang="en-US" smtClean="0"/>
+              <a:rPr lang="en-US"/>
               <a:t>Click to edit Master text styles</a:t>
             </a:r>
           </a:p>
           <a:p>
             <a:pPr lvl="1"/>
             <a:r>
-              <a:rPr lang="en-US" smtClean="0"/>
+              <a:rPr lang="en-US"/>
               <a:t>Second level</a:t>
             </a:r>
           </a:p>
           <a:p>
             <a:pPr lvl="2"/>
             <a:r>
-              <a:rPr lang="en-US" smtClean="0"/>
+              <a:rPr lang="en-US"/>
               <a:t>Third level</a:t>
             </a:r>
           </a:p>
           <a:p>
             <a:pPr lvl="3"/>
             <a:r>
-              <a:rPr lang="en-US" smtClean="0"/>
+              <a:rPr lang="en-US"/>
               <a:t>Fourth level</a:t>
             </a:r>
           </a:p>
           <a:p>
             <a:pPr lvl="4"/>
             <a:r>
-              <a:rPr lang="en-US" smtClean="0"/>
+              <a:rPr lang="en-US"/>
               <a:t>Fifth level</a:t>
             </a:r>
-            <a:endParaRPr lang="en-US"/>
           </a:p>
         </p:txBody>
       </p:sp>
@@ -1773,7 +1774,7 @@
           <a:p>
             <a:fld id="{5BCAD085-E8A6-8845-BD4E-CB4CCA059FC4}" type="datetimeFigureOut">
               <a:rPr lang="en-US" smtClean="0"/>
-              <a:t>1/27/13</a:t>
+              <a:t>8/11/2026</a:t>
             </a:fld>
             <a:endParaRPr lang="en-US"/>
           </a:p>
@@ -1867,10 +1868,9 @@
           <a:lstStyle/>
           <a:p>
             <a:r>
-              <a:rPr lang="en-US" smtClean="0"/>
+              <a:rPr lang="en-US"/>
               <a:t>Click to edit Master title style</a:t>
             </a:r>
-            <a:endParaRPr lang="en-US"/>
           </a:p>
         </p:txBody>
       </p:sp>
@@ -1891,7 +1891,7 @@
           <a:p>
             <a:fld id="{5BCAD085-E8A6-8845-BD4E-CB4CCA059FC4}" type="datetimeFigureOut">
               <a:rPr lang="en-US" smtClean="0"/>
-              <a:t>1/27/13</a:t>
+              <a:t>8/11/2026</a:t>
             </a:fld>
             <a:endParaRPr lang="en-US"/>
           </a:p>
@@ -1986,7 +1986,7 @@
           <a:p>
             <a:fld id="{5BCAD085-E8A6-8845-BD4E-CB4CCA059FC4}" type="datetimeFigureOut">
               <a:rPr lang="en-US" smtClean="0"/>
-              <a:t>1/27/13</a:t>
+              <a:t>8/11/2026</a:t>
             </a:fld>
             <a:endParaRPr lang="en-US"/>
           </a:p>
@@ -2089,10 +2089,9 @@
           </a:lstStyle>
           <a:p>
             <a:r>
-              <a:rPr lang="en-US" smtClean="0"/>
+              <a:rPr lang="en-US"/>
               <a:t>Click to edit Master title style</a:t>
             </a:r>
-            <a:endParaRPr lang="en-US"/>
           </a:p>
         </p:txBody>
       </p:sp>
@@ -2146,38 +2145,37 @@
           <a:p>
             <a:pPr lvl="0"/>
             <a:r>
-              <a:rPr lang="en-US" smtClean="0"/>
+              <a:rPr lang="en-US"/>
               <a:t>Click to edit Master text styles</a:t>
             </a:r>
           </a:p>
           <a:p>
             <a:pPr lvl="1"/>
             <a:r>
-              <a:rPr lang="en-US" smtClean="0"/>
+              <a:rPr lang="en-US"/>
               <a:t>Second level</a:t>
             </a:r>
           </a:p>
           <a:p>
             <a:pPr lvl="2"/>
             <a:r>
-              <a:rPr lang="en-US" smtClean="0"/>
+              <a:rPr lang="en-US"/>
               <a:t>Third level</a:t>
             </a:r>
           </a:p>
           <a:p>
             <a:pPr lvl="3"/>
             <a:r>
-              <a:rPr lang="en-US" smtClean="0"/>
+              <a:rPr lang="en-US"/>
               <a:t>Fourth level</a:t>
             </a:r>
           </a:p>
           <a:p>
             <a:pPr lvl="4"/>
             <a:r>
-              <a:rPr lang="en-US" smtClean="0"/>
+              <a:rPr lang="en-US"/>
               <a:t>Fifth level</a:t>
             </a:r>
-            <a:endParaRPr lang="en-US"/>
           </a:p>
         </p:txBody>
       </p:sp>
@@ -2240,7 +2238,7 @@
           <a:p>
             <a:pPr lvl="0"/>
             <a:r>
-              <a:rPr lang="en-US" smtClean="0"/>
+              <a:rPr lang="en-US"/>
               <a:t>Click to edit Master text styles</a:t>
             </a:r>
           </a:p>
@@ -2263,7 +2261,7 @@
           <a:p>
             <a:fld id="{5BCAD085-E8A6-8845-BD4E-CB4CCA059FC4}" type="datetimeFigureOut">
               <a:rPr lang="en-US" smtClean="0"/>
-              <a:t>1/27/13</a:t>
+              <a:t>8/11/2026</a:t>
             </a:fld>
             <a:endParaRPr lang="en-US"/>
           </a:p>
@@ -2366,10 +2364,9 @@
           </a:lstStyle>
           <a:p>
             <a:r>
-              <a:rPr lang="en-US" smtClean="0"/>
+              <a:rPr lang="en-US"/>
               <a:t>Click to edit Master title style</a:t>
             </a:r>
-            <a:endParaRPr lang="en-US"/>
           </a:p>
         </p:txBody>
       </p:sp>
@@ -2493,7 +2490,7 @@
           <a:p>
             <a:pPr lvl="0"/>
             <a:r>
-              <a:rPr lang="en-US" smtClean="0"/>
+              <a:rPr lang="en-US"/>
               <a:t>Click to edit Master text styles</a:t>
             </a:r>
           </a:p>
@@ -2516,7 +2513,7 @@
           <a:p>
             <a:fld id="{5BCAD085-E8A6-8845-BD4E-CB4CCA059FC4}" type="datetimeFigureOut">
               <a:rPr lang="en-US" smtClean="0"/>
-              <a:t>1/27/13</a:t>
+              <a:t>8/11/2026</a:t>
             </a:fld>
             <a:endParaRPr lang="en-US"/>
           </a:p>
@@ -2625,10 +2622,9 @@
           <a:lstStyle/>
           <a:p>
             <a:r>
-              <a:rPr lang="en-US" smtClean="0"/>
+              <a:rPr lang="en-US"/>
               <a:t>Click to edit Master title style</a:t>
             </a:r>
-            <a:endParaRPr lang="en-US"/>
           </a:p>
         </p:txBody>
       </p:sp>
@@ -2659,38 +2655,37 @@
           <a:p>
             <a:pPr lvl="0"/>
             <a:r>
-              <a:rPr lang="en-US" smtClean="0"/>
+              <a:rPr lang="en-US"/>
               <a:t>Click to edit Master text styles</a:t>
             </a:r>
           </a:p>
           <a:p>
             <a:pPr lvl="1"/>
             <a:r>
-              <a:rPr lang="en-US" smtClean="0"/>
+              <a:rPr lang="en-US"/>
               <a:t>Second level</a:t>
             </a:r>
           </a:p>
           <a:p>
             <a:pPr lvl="2"/>
             <a:r>
-              <a:rPr lang="en-US" smtClean="0"/>
+              <a:rPr lang="en-US"/>
               <a:t>Third level</a:t>
             </a:r>
           </a:p>
           <a:p>
             <a:pPr lvl="3"/>
             <a:r>
-              <a:rPr lang="en-US" smtClean="0"/>
+              <a:rPr lang="en-US"/>
               <a:t>Fourth level</a:t>
             </a:r>
           </a:p>
           <a:p>
             <a:pPr lvl="4"/>
             <a:r>
-              <a:rPr lang="en-US" smtClean="0"/>
+              <a:rPr lang="en-US"/>
               <a:t>Fifth level</a:t>
             </a:r>
-            <a:endParaRPr lang="en-US"/>
           </a:p>
         </p:txBody>
       </p:sp>
@@ -2729,7 +2724,7 @@
           <a:p>
             <a:fld id="{5BCAD085-E8A6-8845-BD4E-CB4CCA059FC4}" type="datetimeFigureOut">
               <a:rPr lang="en-US" smtClean="0"/>
-              <a:t>1/27/13</a:t>
+              <a:t>8/11/2026</a:t>
             </a:fld>
             <a:endParaRPr lang="en-US"/>
           </a:p>
@@ -3088,7 +3083,7 @@
 </file>
 
 <file path=ppt/slides/slide1.xml><?xml version="1.0" encoding="utf-8"?>
-<p:sld xmlns:a="http://schemas.openxmlformats.org/drawingml/2006/main" xmlns:p="http://schemas.openxmlformats.org/presentationml/2006/main" xmlns:r="http://schemas.openxmlformats.org/officeDocument/2006/relationships">
+<p:sld xmlns:a="http://schemas.openxmlformats.org/drawingml/2006/main" xmlns:r="http://schemas.openxmlformats.org/officeDocument/2006/relationships" xmlns:p="http://schemas.openxmlformats.org/presentationml/2006/main">
   <p:cSld>
     <p:bg>
       <p:bgPr>
@@ -3104,7 +3099,14 @@
         <p:cNvGrpSpPr/>
         <p:nvPr/>
       </p:nvGrpSpPr>
-      <p:grpSpPr/>
+      <p:grpSpPr>
+        <a:xfrm>
+          <a:off x="0" y="0"/>
+          <a:ext cx="0" cy="0"/>
+          <a:chOff x="0" y="0"/>
+          <a:chExt cx="0" cy="0"/>
+        </a:xfrm>
+      </p:grpSpPr>
       <p:sp>
         <p:nvSpPr>
           <p:cNvPr id="2" name="Rectangle 1"/>
@@ -3145,6 +3147,7 @@
           <a:lstStyle/>
           <a:p>
             <a:pPr algn="ctr"/>
+            <a:endParaRPr/>
           </a:p>
         </p:txBody>
       </p:sp>
@@ -3188,6 +3191,7 @@
           <a:lstStyle/>
           <a:p>
             <a:pPr algn="ctr"/>
+            <a:endParaRPr/>
           </a:p>
         </p:txBody>
       </p:sp>
@@ -3231,6 +3235,7 @@
           <a:lstStyle/>
           <a:p>
             <a:pPr algn="ctr"/>
+            <a:endParaRPr/>
           </a:p>
         </p:txBody>
       </p:sp>
@@ -3274,6 +3279,7 @@
           <a:lstStyle/>
           <a:p>
             <a:pPr algn="ctr"/>
+            <a:endParaRPr/>
           </a:p>
         </p:txBody>
       </p:sp>
@@ -3387,6 +3393,7 @@
           <a:lstStyle/>
           <a:p>
             <a:pPr algn="ctr"/>
+            <a:endParaRPr/>
           </a:p>
         </p:txBody>
       </p:sp>
@@ -3594,6 +3601,7 @@
           <a:lstStyle/>
           <a:p>
             <a:pPr algn="ctr"/>
+            <a:endParaRPr/>
           </a:p>
         </p:txBody>
       </p:sp>
@@ -3746,7 +3754,7 @@
 </file>
 
 <file path=ppt/slides/slide10.xml><?xml version="1.0" encoding="utf-8"?>
-<p:sld xmlns:a="http://schemas.openxmlformats.org/drawingml/2006/main" xmlns:p="http://schemas.openxmlformats.org/presentationml/2006/main" xmlns:r="http://schemas.openxmlformats.org/officeDocument/2006/relationships">
+<p:sld xmlns:a="http://schemas.openxmlformats.org/drawingml/2006/main" xmlns:r="http://schemas.openxmlformats.org/officeDocument/2006/relationships" xmlns:p="http://schemas.openxmlformats.org/presentationml/2006/main">
   <p:cSld>
     <p:bg>
       <p:bgPr>
@@ -3762,7 +3770,14 @@
         <p:cNvGrpSpPr/>
         <p:nvPr/>
       </p:nvGrpSpPr>
-      <p:grpSpPr/>
+      <p:grpSpPr>
+        <a:xfrm>
+          <a:off x="0" y="0"/>
+          <a:ext cx="0" cy="0"/>
+          <a:chOff x="0" y="0"/>
+          <a:chExt cx="0" cy="0"/>
+        </a:xfrm>
+      </p:grpSpPr>
       <p:sp>
         <p:nvSpPr>
           <p:cNvPr id="2" name="Rectangle 1"/>
@@ -3803,6 +3818,7 @@
           <a:lstStyle/>
           <a:p>
             <a:pPr algn="ctr"/>
+            <a:endParaRPr/>
           </a:p>
         </p:txBody>
       </p:sp>
@@ -3846,6 +3862,7 @@
           <a:lstStyle/>
           <a:p>
             <a:pPr algn="ctr"/>
+            <a:endParaRPr/>
           </a:p>
         </p:txBody>
       </p:sp>
@@ -3889,6 +3906,7 @@
           <a:lstStyle/>
           <a:p>
             <a:pPr algn="ctr"/>
+            <a:endParaRPr/>
           </a:p>
         </p:txBody>
       </p:sp>
@@ -3932,6 +3950,7 @@
           <a:lstStyle/>
           <a:p>
             <a:pPr algn="ctr"/>
+            <a:endParaRPr/>
           </a:p>
         </p:txBody>
       </p:sp>
@@ -4045,6 +4064,7 @@
           <a:lstStyle/>
           <a:p>
             <a:pPr algn="ctr"/>
+            <a:endParaRPr/>
           </a:p>
         </p:txBody>
       </p:sp>
@@ -4123,6 +4143,7 @@
           <a:lstStyle/>
           <a:p>
             <a:pPr algn="ctr"/>
+            <a:endParaRPr/>
           </a:p>
         </p:txBody>
       </p:sp>
@@ -4166,6 +4187,7 @@
           <a:lstStyle/>
           <a:p>
             <a:pPr algn="ctr"/>
+            <a:endParaRPr/>
           </a:p>
         </p:txBody>
       </p:sp>
@@ -4268,6 +4290,7 @@
           <a:lstStyle/>
           <a:p>
             <a:pPr algn="ctr"/>
+            <a:endParaRPr/>
           </a:p>
         </p:txBody>
       </p:sp>
@@ -4311,6 +4334,7 @@
           <a:lstStyle/>
           <a:p>
             <a:pPr algn="ctr"/>
+            <a:endParaRPr/>
           </a:p>
         </p:txBody>
       </p:sp>
@@ -4413,6 +4437,7 @@
           <a:lstStyle/>
           <a:p>
             <a:pPr algn="ctr"/>
+            <a:endParaRPr/>
           </a:p>
         </p:txBody>
       </p:sp>
@@ -4456,6 +4481,7 @@
           <a:lstStyle/>
           <a:p>
             <a:pPr algn="ctr"/>
+            <a:endParaRPr/>
           </a:p>
         </p:txBody>
       </p:sp>
@@ -4558,6 +4584,7 @@
           <a:lstStyle/>
           <a:p>
             <a:pPr algn="ctr"/>
+            <a:endParaRPr/>
           </a:p>
         </p:txBody>
       </p:sp>
@@ -4601,6 +4628,7 @@
           <a:lstStyle/>
           <a:p>
             <a:pPr algn="ctr"/>
+            <a:endParaRPr/>
           </a:p>
         </p:txBody>
       </p:sp>
@@ -4703,6 +4731,7 @@
           <a:lstStyle/>
           <a:p>
             <a:pPr algn="ctr"/>
+            <a:endParaRPr/>
           </a:p>
         </p:txBody>
       </p:sp>
@@ -4855,7 +4884,7 @@
 </file>
 
 <file path=ppt/slides/slide2.xml><?xml version="1.0" encoding="utf-8"?>
-<p:sld xmlns:a="http://schemas.openxmlformats.org/drawingml/2006/main" xmlns:p="http://schemas.openxmlformats.org/presentationml/2006/main" xmlns:r="http://schemas.openxmlformats.org/officeDocument/2006/relationships">
+<p:sld xmlns:a="http://schemas.openxmlformats.org/drawingml/2006/main" xmlns:r="http://schemas.openxmlformats.org/officeDocument/2006/relationships" xmlns:p="http://schemas.openxmlformats.org/presentationml/2006/main">
   <p:cSld>
     <p:bg>
       <p:bgPr>
@@ -4871,7 +4900,14 @@
         <p:cNvGrpSpPr/>
         <p:nvPr/>
       </p:nvGrpSpPr>
-      <p:grpSpPr/>
+      <p:grpSpPr>
+        <a:xfrm>
+          <a:off x="0" y="0"/>
+          <a:ext cx="0" cy="0"/>
+          <a:chOff x="0" y="0"/>
+          <a:chExt cx="0" cy="0"/>
+        </a:xfrm>
+      </p:grpSpPr>
       <p:pic>
         <p:nvPicPr>
           <p:cNvPr id="2" name="Picture 1" descr="agentic_stack_diagram.png"/>
@@ -4888,8 +4924,8 @@
         </p:blipFill>
         <p:spPr>
           <a:xfrm>
-            <a:off x="0" y="0"/>
-            <a:ext cx="12188952" cy="3291840"/>
+            <a:off x="457200" y="777240"/>
+            <a:ext cx="5303520" cy="5303520"/>
           </a:xfrm>
           <a:prstGeom prst="rect">
             <a:avLst/>
@@ -4904,51 +4940,8 @@
         </p:nvSpPr>
         <p:spPr>
           <a:xfrm>
-            <a:off x="0" y="3200400"/>
-            <a:ext cx="12188952" cy="3657600"/>
-          </a:xfrm>
-          <a:prstGeom prst="rect">
-            <a:avLst/>
-          </a:prstGeom>
-          <a:solidFill>
-            <a:srgbClr val="0D2229"/>
-          </a:solidFill>
-          <a:ln>
-            <a:noFill/>
-          </a:ln>
-        </p:spPr>
-        <p:style>
-          <a:lnRef idx="1">
-            <a:schemeClr val="accent1"/>
-          </a:lnRef>
-          <a:fillRef idx="3">
-            <a:schemeClr val="accent1"/>
-          </a:fillRef>
-          <a:effectRef idx="2">
-            <a:schemeClr val="accent1"/>
-          </a:effectRef>
-          <a:fontRef idx="minor">
-            <a:schemeClr val="lt1"/>
-          </a:fontRef>
-        </p:style>
-        <p:txBody>
-          <a:bodyPr rtlCol="0" anchor="ctr"/>
-          <a:lstStyle/>
-          <a:p>
-            <a:pPr algn="ctr"/>
-          </a:p>
-        </p:txBody>
-      </p:sp>
-      <p:sp>
-        <p:nvSpPr>
-          <p:cNvPr id="4" name="Rectangle 3"/>
-          <p:cNvSpPr/>
-          <p:nvPr/>
-        </p:nvSpPr>
-        <p:spPr>
-          <a:xfrm>
-            <a:off x="0" y="3200400"/>
-            <a:ext cx="12188952" cy="45720"/>
+            <a:off x="6035040" y="777240"/>
+            <a:ext cx="27432" cy="5303520"/>
           </a:xfrm>
           <a:prstGeom prst="rect">
             <a:avLst/>
@@ -4979,6 +4972,7 @@
           <a:lstStyle/>
           <a:p>
             <a:pPr algn="ctr"/>
+            <a:endParaRPr/>
           </a:p>
         </p:txBody>
       </p:sp>
@@ -4990,8 +4984,8 @@
         </p:nvSpPr>
         <p:spPr>
           <a:xfrm>
-            <a:off x="457200" y="3291840"/>
-            <a:ext cx="11430000" cy="640080"/>
+            <a:off x="6400800" y="777240"/>
+            <a:ext cx="5330952" cy="430887"/>
           </a:xfrm>
           <a:prstGeom prst="rect">
             <a:avLst/>
@@ -5006,7 +5000,7 @@
           <a:p>
             <a:pPr algn="r" rtl="1"/>
             <a:r>
-              <a:rPr sz="2600" b="1" i="0">
+              <a:rPr lang="ar-DZ" sz="2200" b="1" i="0">
                 <a:solidFill>
                   <a:srgbClr val="FFFFFF"/>
                 </a:solidFill>
@@ -5025,8 +5019,8 @@
         </p:nvSpPr>
         <p:spPr>
           <a:xfrm>
-            <a:off x="457200" y="3886200"/>
-            <a:ext cx="11430000" cy="365760"/>
+            <a:off x="6400800" y="1447800"/>
+            <a:ext cx="5330952" cy="292388"/>
           </a:xfrm>
           <a:prstGeom prst="rect">
             <a:avLst/>
@@ -5041,7 +5035,7 @@
           <a:p>
             <a:pPr algn="r" rtl="0"/>
             <a:r>
-              <a:rPr sz="1500" b="0" i="0">
+              <a:rPr lang="en-US" sz="1300" b="0" i="0">
                 <a:solidFill>
                   <a:srgbClr val="00D2FF"/>
                 </a:solidFill>
@@ -5060,8 +5054,8 @@
         </p:nvSpPr>
         <p:spPr>
           <a:xfrm>
-            <a:off x="365760" y="4343400"/>
-            <a:ext cx="3794760" cy="2286000"/>
+            <a:off x="6400800" y="2011680"/>
+            <a:ext cx="5330952" cy="1280160"/>
           </a:xfrm>
           <a:prstGeom prst="rect">
             <a:avLst/>
@@ -5094,6 +5088,7 @@
           <a:lstStyle/>
           <a:p>
             <a:pPr algn="ctr"/>
+            <a:endParaRPr/>
           </a:p>
         </p:txBody>
       </p:sp>
@@ -5105,8 +5100,8 @@
         </p:nvSpPr>
         <p:spPr>
           <a:xfrm>
-            <a:off x="365760" y="4389120"/>
-            <a:ext cx="3794760" cy="411480"/>
+            <a:off x="6400800" y="2057400"/>
+            <a:ext cx="5330952" cy="320040"/>
           </a:xfrm>
           <a:prstGeom prst="rect">
             <a:avLst/>
@@ -5140,8 +5135,8 @@
         </p:nvSpPr>
         <p:spPr>
           <a:xfrm>
-            <a:off x="365760" y="4754880"/>
-            <a:ext cx="3794760" cy="822960"/>
+            <a:off x="6400800" y="2377440"/>
+            <a:ext cx="5330952" cy="523220"/>
           </a:xfrm>
           <a:prstGeom prst="rect">
             <a:avLst/>
@@ -5156,7 +5151,7 @@
           <a:p>
             <a:pPr algn="ctr" rtl="0"/>
             <a:r>
-              <a:rPr sz="1600" b="1" i="0">
+              <a:rPr lang="ar-DZ" sz="1400" b="1" i="0">
                 <a:solidFill>
                   <a:srgbClr val="FFFFFF"/>
                 </a:solidFill>
@@ -5168,13 +5163,22 @@
           <a:p>
             <a:pPr algn="ctr" rtl="0"/>
             <a:r>
-              <a:rPr sz="1600" b="1" i="0">
+              <a:rPr lang="ar-DZ" sz="1400" b="1" i="0">
                 <a:solidFill>
                   <a:srgbClr val="FFFFFF"/>
                 </a:solidFill>
                 <a:latin typeface="Arial"/>
               </a:rPr>
-              <a:t>(Dashboard Era)</a:t>
+              <a:t>(</a:t>
+            </a:r>
+            <a:r>
+              <a:rPr lang="en-US" sz="1400" b="1" i="0">
+                <a:solidFill>
+                  <a:srgbClr val="FFFFFF"/>
+                </a:solidFill>
+                <a:latin typeface="Arial"/>
+              </a:rPr>
+              <a:t>Dashboard Era)</a:t>
             </a:r>
           </a:p>
         </p:txBody>
@@ -5187,8 +5191,8 @@
         </p:nvSpPr>
         <p:spPr>
           <a:xfrm>
-            <a:off x="365760" y="5577840"/>
-            <a:ext cx="3794760" cy="914400"/>
+            <a:off x="6400800" y="2834640"/>
+            <a:ext cx="5330952" cy="446276"/>
           </a:xfrm>
           <a:prstGeom prst="rect">
             <a:avLst/>
@@ -5203,7 +5207,7 @@
           <a:p>
             <a:pPr algn="ctr" rtl="1"/>
             <a:r>
-              <a:rPr sz="1300" b="0" i="0">
+              <a:rPr lang="ar-DZ" sz="1150" b="0" i="0">
                 <a:solidFill>
                   <a:srgbClr val="88AABB"/>
                 </a:solidFill>
@@ -5215,7 +5219,7 @@
           <a:p>
             <a:pPr algn="ctr" rtl="1"/>
             <a:r>
-              <a:rPr sz="1300" b="0" i="0">
+              <a:rPr lang="ar-DZ" sz="1150" b="0" i="0">
                 <a:solidFill>
                   <a:srgbClr val="88AABB"/>
                 </a:solidFill>
@@ -5234,8 +5238,8 @@
         </p:nvSpPr>
         <p:spPr>
           <a:xfrm>
-            <a:off x="4297680" y="4343400"/>
-            <a:ext cx="3794760" cy="2286000"/>
+            <a:off x="6400800" y="3383280"/>
+            <a:ext cx="5330952" cy="1280160"/>
           </a:xfrm>
           <a:prstGeom prst="rect">
             <a:avLst/>
@@ -5268,6 +5272,7 @@
           <a:lstStyle/>
           <a:p>
             <a:pPr algn="ctr"/>
+            <a:endParaRPr/>
           </a:p>
         </p:txBody>
       </p:sp>
@@ -5279,8 +5284,8 @@
         </p:nvSpPr>
         <p:spPr>
           <a:xfrm>
-            <a:off x="4297680" y="4389120"/>
-            <a:ext cx="3794760" cy="411480"/>
+            <a:off x="6400800" y="3429000"/>
+            <a:ext cx="5330952" cy="320040"/>
           </a:xfrm>
           <a:prstGeom prst="rect">
             <a:avLst/>
@@ -5314,8 +5319,8 @@
         </p:nvSpPr>
         <p:spPr>
           <a:xfrm>
-            <a:off x="4297680" y="4754880"/>
-            <a:ext cx="3794760" cy="822960"/>
+            <a:off x="6400800" y="3749040"/>
+            <a:ext cx="5330952" cy="523220"/>
           </a:xfrm>
           <a:prstGeom prst="rect">
             <a:avLst/>
@@ -5330,7 +5335,7 @@
           <a:p>
             <a:pPr algn="ctr" rtl="0"/>
             <a:r>
-              <a:rPr sz="1600" b="1" i="0">
+              <a:rPr lang="ar-DZ" sz="1400" b="1" i="0">
                 <a:solidFill>
                   <a:srgbClr val="FFFFFF"/>
                 </a:solidFill>
@@ -5342,13 +5347,22 @@
           <a:p>
             <a:pPr algn="ctr" rtl="0"/>
             <a:r>
-              <a:rPr sz="1600" b="1" i="0">
+              <a:rPr lang="ar-DZ" sz="1400" b="1" i="0">
                 <a:solidFill>
                   <a:srgbClr val="FFFFFF"/>
                 </a:solidFill>
                 <a:latin typeface="Arial"/>
               </a:rPr>
-              <a:t>(Copilot Era)</a:t>
+              <a:t>(</a:t>
+            </a:r>
+            <a:r>
+              <a:rPr lang="en-US" sz="1400" b="1" i="0">
+                <a:solidFill>
+                  <a:srgbClr val="FFFFFF"/>
+                </a:solidFill>
+                <a:latin typeface="Arial"/>
+              </a:rPr>
+              <a:t>Copilot Era)</a:t>
             </a:r>
           </a:p>
         </p:txBody>
@@ -5361,8 +5375,8 @@
         </p:nvSpPr>
         <p:spPr>
           <a:xfrm>
-            <a:off x="4297680" y="5577840"/>
-            <a:ext cx="3794760" cy="914400"/>
+            <a:off x="6400800" y="4206240"/>
+            <a:ext cx="5330952" cy="446276"/>
           </a:xfrm>
           <a:prstGeom prst="rect">
             <a:avLst/>
@@ -5377,7 +5391,7 @@
           <a:p>
             <a:pPr algn="ctr" rtl="1"/>
             <a:r>
-              <a:rPr sz="1300" b="0" i="0">
+              <a:rPr lang="ar-DZ" sz="1150" b="0" i="0">
                 <a:solidFill>
                   <a:srgbClr val="88AABB"/>
                 </a:solidFill>
@@ -5389,7 +5403,7 @@
           <a:p>
             <a:pPr algn="ctr" rtl="1"/>
             <a:r>
-              <a:rPr sz="1300" b="0" i="0">
+              <a:rPr lang="ar-DZ" sz="1150" b="0" i="0">
                 <a:solidFill>
                   <a:srgbClr val="88AABB"/>
                 </a:solidFill>
@@ -5408,8 +5422,8 @@
         </p:nvSpPr>
         <p:spPr>
           <a:xfrm>
-            <a:off x="8229600" y="4343400"/>
-            <a:ext cx="3794760" cy="2286000"/>
+            <a:off x="6400800" y="4754880"/>
+            <a:ext cx="5330952" cy="1280160"/>
           </a:xfrm>
           <a:prstGeom prst="rect">
             <a:avLst/>
@@ -5442,6 +5456,7 @@
           <a:lstStyle/>
           <a:p>
             <a:pPr algn="ctr"/>
+            <a:endParaRPr/>
           </a:p>
         </p:txBody>
       </p:sp>
@@ -5453,8 +5468,8 @@
         </p:nvSpPr>
         <p:spPr>
           <a:xfrm>
-            <a:off x="8229600" y="4389120"/>
-            <a:ext cx="3794760" cy="411480"/>
+            <a:off x="6400800" y="4800600"/>
+            <a:ext cx="5330952" cy="320040"/>
           </a:xfrm>
           <a:prstGeom prst="rect">
             <a:avLst/>
@@ -5488,8 +5503,8 @@
         </p:nvSpPr>
         <p:spPr>
           <a:xfrm>
-            <a:off x="8229600" y="4754880"/>
-            <a:ext cx="3794760" cy="822960"/>
+            <a:off x="6400800" y="5120640"/>
+            <a:ext cx="5330952" cy="523220"/>
           </a:xfrm>
           <a:prstGeom prst="rect">
             <a:avLst/>
@@ -5504,7 +5519,7 @@
           <a:p>
             <a:pPr algn="ctr" rtl="0"/>
             <a:r>
-              <a:rPr sz="1600" b="1" i="0">
+              <a:rPr lang="ar-DZ" sz="1400" b="1" i="0">
                 <a:solidFill>
                   <a:srgbClr val="FFFFFF"/>
                 </a:solidFill>
@@ -5516,13 +5531,22 @@
           <a:p>
             <a:pPr algn="ctr" rtl="0"/>
             <a:r>
-              <a:rPr sz="1600" b="1" i="0">
+              <a:rPr lang="ar-DZ" sz="1400" b="1" i="0">
                 <a:solidFill>
                   <a:srgbClr val="FFFFFF"/>
                 </a:solidFill>
                 <a:latin typeface="Arial"/>
               </a:rPr>
-              <a:t>(Agentic AI Era)</a:t>
+              <a:t>(</a:t>
+            </a:r>
+            <a:r>
+              <a:rPr lang="en-US" sz="1400" b="1" i="0">
+                <a:solidFill>
+                  <a:srgbClr val="FFFFFF"/>
+                </a:solidFill>
+                <a:latin typeface="Arial"/>
+              </a:rPr>
+              <a:t>Agentic AI Era)</a:t>
             </a:r>
           </a:p>
         </p:txBody>
@@ -5535,8 +5559,8 @@
         </p:nvSpPr>
         <p:spPr>
           <a:xfrm>
-            <a:off x="8229600" y="5577840"/>
-            <a:ext cx="3794760" cy="914400"/>
+            <a:off x="6400800" y="5577840"/>
+            <a:ext cx="5330952" cy="446276"/>
           </a:xfrm>
           <a:prstGeom prst="rect">
             <a:avLst/>
@@ -5551,7 +5575,7 @@
           <a:p>
             <a:pPr algn="ctr" rtl="1"/>
             <a:r>
-              <a:rPr sz="1300" b="0" i="0">
+              <a:rPr lang="ar-DZ" sz="1150" b="0" i="0">
                 <a:solidFill>
                   <a:srgbClr val="88AABB"/>
                 </a:solidFill>
@@ -5563,7 +5587,7 @@
           <a:p>
             <a:pPr algn="ctr" rtl="1"/>
             <a:r>
-              <a:rPr sz="1300" b="0" i="0">
+              <a:rPr lang="ar-DZ" sz="1150" b="0" i="0">
                 <a:solidFill>
                   <a:srgbClr val="88AABB"/>
                 </a:solidFill>
@@ -5653,7 +5677,7 @@
 </file>
 
 <file path=ppt/slides/slide3.xml><?xml version="1.0" encoding="utf-8"?>
-<p:sld xmlns:a="http://schemas.openxmlformats.org/drawingml/2006/main" xmlns:p="http://schemas.openxmlformats.org/presentationml/2006/main" xmlns:r="http://schemas.openxmlformats.org/officeDocument/2006/relationships">
+<p:sld xmlns:a="http://schemas.openxmlformats.org/drawingml/2006/main" xmlns:r="http://schemas.openxmlformats.org/officeDocument/2006/relationships" xmlns:p="http://schemas.openxmlformats.org/presentationml/2006/main">
   <p:cSld>
     <p:bg>
       <p:bgPr>
@@ -5669,7 +5693,14 @@
         <p:cNvGrpSpPr/>
         <p:nvPr/>
       </p:nvGrpSpPr>
-      <p:grpSpPr/>
+      <p:grpSpPr>
+        <a:xfrm>
+          <a:off x="0" y="0"/>
+          <a:ext cx="0" cy="0"/>
+          <a:chOff x="0" y="0"/>
+          <a:chExt cx="0" cy="0"/>
+        </a:xfrm>
+      </p:grpSpPr>
       <p:sp>
         <p:nvSpPr>
           <p:cNvPr id="2" name="Rectangle 1"/>
@@ -5710,6 +5741,7 @@
           <a:lstStyle/>
           <a:p>
             <a:pPr algn="ctr"/>
+            <a:endParaRPr/>
           </a:p>
         </p:txBody>
       </p:sp>
@@ -5753,6 +5785,7 @@
           <a:lstStyle/>
           <a:p>
             <a:pPr algn="ctr"/>
+            <a:endParaRPr/>
           </a:p>
         </p:txBody>
       </p:sp>
@@ -5866,6 +5899,7 @@
           <a:lstStyle/>
           <a:p>
             <a:pPr algn="ctr"/>
+            <a:endParaRPr/>
           </a:p>
         </p:txBody>
       </p:sp>
@@ -5909,6 +5943,7 @@
           <a:lstStyle/>
           <a:p>
             <a:pPr algn="ctr"/>
+            <a:endParaRPr/>
           </a:p>
         </p:txBody>
       </p:sp>
@@ -5952,6 +5987,7 @@
           <a:lstStyle/>
           <a:p>
             <a:pPr algn="ctr"/>
+            <a:endParaRPr/>
           </a:p>
         </p:txBody>
       </p:sp>
@@ -6112,6 +6148,7 @@
           <a:lstStyle/>
           <a:p>
             <a:pPr algn="ctr"/>
+            <a:endParaRPr/>
           </a:p>
         </p:txBody>
       </p:sp>
@@ -6354,6 +6391,7 @@
           <a:lstStyle/>
           <a:p>
             <a:pPr algn="ctr"/>
+            <a:endParaRPr/>
           </a:p>
         </p:txBody>
       </p:sp>
@@ -6397,6 +6435,7 @@
           <a:lstStyle/>
           <a:p>
             <a:pPr algn="ctr"/>
+            <a:endParaRPr/>
           </a:p>
         </p:txBody>
       </p:sp>
@@ -6440,6 +6479,7 @@
           <a:lstStyle/>
           <a:p>
             <a:pPr algn="ctr"/>
+            <a:endParaRPr/>
           </a:p>
         </p:txBody>
       </p:sp>
@@ -6600,6 +6640,7 @@
           <a:lstStyle/>
           <a:p>
             <a:pPr algn="ctr"/>
+            <a:endParaRPr/>
           </a:p>
         </p:txBody>
       </p:sp>
@@ -6842,6 +6883,7 @@
           <a:lstStyle/>
           <a:p>
             <a:pPr algn="ctr"/>
+            <a:endParaRPr/>
           </a:p>
         </p:txBody>
       </p:sp>
@@ -6885,6 +6927,7 @@
           <a:lstStyle/>
           <a:p>
             <a:pPr algn="ctr"/>
+            <a:endParaRPr/>
           </a:p>
         </p:txBody>
       </p:sp>
@@ -6928,6 +6971,7 @@
           <a:lstStyle/>
           <a:p>
             <a:pPr algn="ctr"/>
+            <a:endParaRPr/>
           </a:p>
         </p:txBody>
       </p:sp>
@@ -7088,6 +7132,7 @@
           <a:lstStyle/>
           <a:p>
             <a:pPr algn="ctr"/>
+            <a:endParaRPr/>
           </a:p>
         </p:txBody>
       </p:sp>
@@ -7369,7 +7414,7 @@
 </file>
 
 <file path=ppt/slides/slide4.xml><?xml version="1.0" encoding="utf-8"?>
-<p:sld xmlns:a="http://schemas.openxmlformats.org/drawingml/2006/main" xmlns:p="http://schemas.openxmlformats.org/presentationml/2006/main" xmlns:r="http://schemas.openxmlformats.org/officeDocument/2006/relationships">
+<p:sld xmlns:a="http://schemas.openxmlformats.org/drawingml/2006/main" xmlns:r="http://schemas.openxmlformats.org/officeDocument/2006/relationships" xmlns:p="http://schemas.openxmlformats.org/presentationml/2006/main">
   <p:cSld>
     <p:bg>
       <p:bgPr>
@@ -7385,7 +7430,14 @@
         <p:cNvGrpSpPr/>
         <p:nvPr/>
       </p:nvGrpSpPr>
-      <p:grpSpPr/>
+      <p:grpSpPr>
+        <a:xfrm>
+          <a:off x="0" y="0"/>
+          <a:ext cx="0" cy="0"/>
+          <a:chOff x="0" y="0"/>
+          <a:chExt cx="0" cy="0"/>
+        </a:xfrm>
+      </p:grpSpPr>
       <p:sp>
         <p:nvSpPr>
           <p:cNvPr id="2" name="Rectangle 1"/>
@@ -7426,6 +7478,7 @@
           <a:lstStyle/>
           <a:p>
             <a:pPr algn="ctr"/>
+            <a:endParaRPr/>
           </a:p>
         </p:txBody>
       </p:sp>
@@ -7469,6 +7522,7 @@
           <a:lstStyle/>
           <a:p>
             <a:pPr algn="ctr"/>
+            <a:endParaRPr/>
           </a:p>
         </p:txBody>
       </p:sp>
@@ -7558,8 +7612,8 @@
         </p:blipFill>
         <p:spPr>
           <a:xfrm>
-            <a:off x="137160" y="1051560"/>
-            <a:ext cx="5669280" cy="5303520"/>
+            <a:off x="320040" y="1051560"/>
+            <a:ext cx="5303520" cy="5303520"/>
           </a:xfrm>
           <a:prstGeom prst="rect">
             <a:avLst/>
@@ -7676,6 +7730,7 @@
           <a:lstStyle/>
           <a:p>
             <a:pPr algn="ctr"/>
+            <a:endParaRPr/>
           </a:p>
         </p:txBody>
       </p:sp>
@@ -7719,6 +7774,7 @@
           <a:lstStyle/>
           <a:p>
             <a:pPr algn="ctr"/>
+            <a:endParaRPr/>
           </a:p>
         </p:txBody>
       </p:sp>
@@ -7762,6 +7818,7 @@
           <a:lstStyle/>
           <a:p>
             <a:pPr algn="ctr"/>
+            <a:endParaRPr/>
           </a:p>
         </p:txBody>
       </p:sp>
@@ -7910,6 +7967,7 @@
           <a:lstStyle/>
           <a:p>
             <a:pPr algn="ctr"/>
+            <a:endParaRPr/>
           </a:p>
         </p:txBody>
       </p:sp>
@@ -7953,6 +8011,7 @@
           <a:lstStyle/>
           <a:p>
             <a:pPr algn="ctr"/>
+            <a:endParaRPr/>
           </a:p>
         </p:txBody>
       </p:sp>
@@ -8101,6 +8160,7 @@
           <a:lstStyle/>
           <a:p>
             <a:pPr algn="ctr"/>
+            <a:endParaRPr/>
           </a:p>
         </p:txBody>
       </p:sp>
@@ -8144,6 +8204,7 @@
           <a:lstStyle/>
           <a:p>
             <a:pPr algn="ctr"/>
+            <a:endParaRPr/>
           </a:p>
         </p:txBody>
       </p:sp>
@@ -8292,6 +8353,7 @@
           <a:lstStyle/>
           <a:p>
             <a:pPr algn="ctr"/>
+            <a:endParaRPr/>
           </a:p>
         </p:txBody>
       </p:sp>
@@ -8335,6 +8397,7 @@
           <a:lstStyle/>
           <a:p>
             <a:pPr algn="ctr"/>
+            <a:endParaRPr/>
           </a:p>
         </p:txBody>
       </p:sp>
@@ -8483,6 +8546,7 @@
           <a:lstStyle/>
           <a:p>
             <a:pPr algn="ctr"/>
+            <a:endParaRPr/>
           </a:p>
         </p:txBody>
       </p:sp>
@@ -8526,6 +8590,7 @@
           <a:lstStyle/>
           <a:p>
             <a:pPr algn="ctr"/>
+            <a:endParaRPr/>
           </a:p>
         </p:txBody>
       </p:sp>
@@ -8713,7 +8778,7 @@
 </file>
 
 <file path=ppt/slides/slide5.xml><?xml version="1.0" encoding="utf-8"?>
-<p:sld xmlns:a="http://schemas.openxmlformats.org/drawingml/2006/main" xmlns:p="http://schemas.openxmlformats.org/presentationml/2006/main" xmlns:r="http://schemas.openxmlformats.org/officeDocument/2006/relationships">
+<p:sld xmlns:a="http://schemas.openxmlformats.org/drawingml/2006/main" xmlns:r="http://schemas.openxmlformats.org/officeDocument/2006/relationships" xmlns:p="http://schemas.openxmlformats.org/presentationml/2006/main">
   <p:cSld>
     <p:bg>
       <p:bgPr>
@@ -8729,7 +8794,14 @@
         <p:cNvGrpSpPr/>
         <p:nvPr/>
       </p:nvGrpSpPr>
-      <p:grpSpPr/>
+      <p:grpSpPr>
+        <a:xfrm>
+          <a:off x="0" y="0"/>
+          <a:ext cx="0" cy="0"/>
+          <a:chOff x="0" y="0"/>
+          <a:chExt cx="0" cy="0"/>
+        </a:xfrm>
+      </p:grpSpPr>
       <p:sp>
         <p:nvSpPr>
           <p:cNvPr id="2" name="Rectangle 1"/>
@@ -8770,6 +8842,7 @@
           <a:lstStyle/>
           <a:p>
             <a:pPr algn="ctr"/>
+            <a:endParaRPr/>
           </a:p>
         </p:txBody>
       </p:sp>
@@ -8883,6 +8956,7 @@
           <a:lstStyle/>
           <a:p>
             <a:pPr algn="ctr"/>
+            <a:endParaRPr/>
           </a:p>
         </p:txBody>
       </p:sp>
@@ -8926,6 +9000,7 @@
           <a:lstStyle/>
           <a:p>
             <a:pPr algn="ctr"/>
+            <a:endParaRPr/>
           </a:p>
         </p:txBody>
       </p:sp>
@@ -9612,6 +9687,7 @@
           <a:lstStyle/>
           <a:p>
             <a:pPr algn="ctr"/>
+            <a:endParaRPr/>
           </a:p>
         </p:txBody>
       </p:sp>
@@ -9655,6 +9731,7 @@
           <a:lstStyle/>
           <a:p>
             <a:pPr algn="ctr"/>
+            <a:endParaRPr/>
           </a:p>
         </p:txBody>
       </p:sp>
@@ -10345,7 +10422,7 @@
 </file>
 
 <file path=ppt/slides/slide6.xml><?xml version="1.0" encoding="utf-8"?>
-<p:sld xmlns:a="http://schemas.openxmlformats.org/drawingml/2006/main" xmlns:p="http://schemas.openxmlformats.org/presentationml/2006/main" xmlns:r="http://schemas.openxmlformats.org/officeDocument/2006/relationships">
+<p:sld xmlns:a="http://schemas.openxmlformats.org/drawingml/2006/main" xmlns:r="http://schemas.openxmlformats.org/officeDocument/2006/relationships" xmlns:p="http://schemas.openxmlformats.org/presentationml/2006/main">
   <p:cSld>
     <p:bg>
       <p:bgPr>
@@ -10361,7 +10438,14 @@
         <p:cNvGrpSpPr/>
         <p:nvPr/>
       </p:nvGrpSpPr>
-      <p:grpSpPr/>
+      <p:grpSpPr>
+        <a:xfrm>
+          <a:off x="0" y="0"/>
+          <a:ext cx="0" cy="0"/>
+          <a:chOff x="0" y="0"/>
+          <a:chExt cx="0" cy="0"/>
+        </a:xfrm>
+      </p:grpSpPr>
       <p:sp>
         <p:nvSpPr>
           <p:cNvPr id="2" name="Rectangle 1"/>
@@ -10402,6 +10486,7 @@
           <a:lstStyle/>
           <a:p>
             <a:pPr algn="ctr"/>
+            <a:endParaRPr/>
           </a:p>
         </p:txBody>
       </p:sp>
@@ -10491,8 +10576,8 @@
         </p:blipFill>
         <p:spPr>
           <a:xfrm>
-            <a:off x="274320" y="1143000"/>
-            <a:ext cx="11612880" cy="3200400"/>
+            <a:off x="365760" y="1181100"/>
+            <a:ext cx="5181600" cy="5181600"/>
           </a:xfrm>
           <a:prstGeom prst="rect">
             <a:avLst/>
@@ -10507,8 +10592,8 @@
         </p:nvSpPr>
         <p:spPr>
           <a:xfrm>
-            <a:off x="0" y="4407408"/>
-            <a:ext cx="12188952" cy="36576"/>
+            <a:off x="0" y="1066800"/>
+            <a:ext cx="12188952" cy="27432"/>
           </a:xfrm>
           <a:prstGeom prst="rect">
             <a:avLst/>
@@ -10539,6 +10624,7 @@
           <a:lstStyle/>
           <a:p>
             <a:pPr algn="ctr"/>
+            <a:endParaRPr/>
           </a:p>
         </p:txBody>
       </p:sp>
@@ -10550,8 +10636,8 @@
         </p:nvSpPr>
         <p:spPr>
           <a:xfrm>
-            <a:off x="274320" y="4480560"/>
-            <a:ext cx="5623560" cy="2194560"/>
+            <a:off x="6035040" y="1143000"/>
+            <a:ext cx="5788152" cy="2468880"/>
           </a:xfrm>
           <a:prstGeom prst="rect">
             <a:avLst/>
@@ -10582,6 +10668,7 @@
           <a:lstStyle/>
           <a:p>
             <a:pPr algn="ctr"/>
+            <a:endParaRPr/>
           </a:p>
         </p:txBody>
       </p:sp>
@@ -10593,8 +10680,8 @@
         </p:nvSpPr>
         <p:spPr>
           <a:xfrm>
-            <a:off x="274320" y="4480560"/>
-            <a:ext cx="54864" cy="2194560"/>
+            <a:off x="6035040" y="1143000"/>
+            <a:ext cx="54864" cy="2468880"/>
           </a:xfrm>
           <a:prstGeom prst="rect">
             <a:avLst/>
@@ -10625,6 +10712,7 @@
           <a:lstStyle/>
           <a:p>
             <a:pPr algn="ctr"/>
+            <a:endParaRPr/>
           </a:p>
         </p:txBody>
       </p:sp>
@@ -10636,8 +10724,8 @@
         </p:nvSpPr>
         <p:spPr>
           <a:xfrm>
-            <a:off x="411480" y="4526280"/>
-            <a:ext cx="5349240" cy="438912"/>
+            <a:off x="6172200" y="1211580"/>
+            <a:ext cx="5513832" cy="438912"/>
           </a:xfrm>
           <a:prstGeom prst="rect">
             <a:avLst/>
@@ -10671,8 +10759,8 @@
         </p:nvSpPr>
         <p:spPr>
           <a:xfrm>
-            <a:off x="411480" y="4937760"/>
-            <a:ext cx="5349240" cy="320040"/>
+            <a:off x="6172200" y="1668780"/>
+            <a:ext cx="5513832" cy="320040"/>
           </a:xfrm>
           <a:prstGeom prst="rect">
             <a:avLst/>
@@ -10706,8 +10794,8 @@
         </p:nvSpPr>
         <p:spPr>
           <a:xfrm>
-            <a:off x="411480" y="5257800"/>
-            <a:ext cx="5349240" cy="320040"/>
+            <a:off x="6172200" y="2057400"/>
+            <a:ext cx="5513832" cy="320040"/>
           </a:xfrm>
           <a:prstGeom prst="rect">
             <a:avLst/>
@@ -10741,8 +10829,8 @@
         </p:nvSpPr>
         <p:spPr>
           <a:xfrm>
-            <a:off x="411480" y="5596128"/>
-            <a:ext cx="5349240" cy="320040"/>
+            <a:off x="6172200" y="2423160"/>
+            <a:ext cx="5513832" cy="320040"/>
           </a:xfrm>
           <a:prstGeom prst="rect">
             <a:avLst/>
@@ -10776,8 +10864,8 @@
         </p:nvSpPr>
         <p:spPr>
           <a:xfrm>
-            <a:off x="411480" y="5934456"/>
-            <a:ext cx="5349240" cy="320040"/>
+            <a:off x="6172200" y="2788920"/>
+            <a:ext cx="5513832" cy="320040"/>
           </a:xfrm>
           <a:prstGeom prst="rect">
             <a:avLst/>
@@ -10811,8 +10899,8 @@
         </p:nvSpPr>
         <p:spPr>
           <a:xfrm>
-            <a:off x="411480" y="6272783"/>
-            <a:ext cx="5349240" cy="320040"/>
+            <a:off x="6172200" y="3154680"/>
+            <a:ext cx="5513832" cy="320040"/>
           </a:xfrm>
           <a:prstGeom prst="rect">
             <a:avLst/>
@@ -10846,8 +10934,8 @@
         </p:nvSpPr>
         <p:spPr>
           <a:xfrm>
-            <a:off x="6263640" y="4480560"/>
-            <a:ext cx="5623560" cy="2194560"/>
+            <a:off x="6035040" y="3840480"/>
+            <a:ext cx="5788152" cy="2468880"/>
           </a:xfrm>
           <a:prstGeom prst="rect">
             <a:avLst/>
@@ -10878,6 +10966,7 @@
           <a:lstStyle/>
           <a:p>
             <a:pPr algn="ctr"/>
+            <a:endParaRPr/>
           </a:p>
         </p:txBody>
       </p:sp>
@@ -10889,8 +10978,8 @@
         </p:nvSpPr>
         <p:spPr>
           <a:xfrm>
-            <a:off x="6263640" y="4480560"/>
-            <a:ext cx="54864" cy="2194560"/>
+            <a:off x="6035040" y="3840480"/>
+            <a:ext cx="54864" cy="2468880"/>
           </a:xfrm>
           <a:prstGeom prst="rect">
             <a:avLst/>
@@ -10921,6 +11010,7 @@
           <a:lstStyle/>
           <a:p>
             <a:pPr algn="ctr"/>
+            <a:endParaRPr/>
           </a:p>
         </p:txBody>
       </p:sp>
@@ -10932,8 +11022,8 @@
         </p:nvSpPr>
         <p:spPr>
           <a:xfrm>
-            <a:off x="6400800" y="4526280"/>
-            <a:ext cx="5349240" cy="438912"/>
+            <a:off x="6172200" y="3909060"/>
+            <a:ext cx="5513832" cy="438912"/>
           </a:xfrm>
           <a:prstGeom prst="rect">
             <a:avLst/>
@@ -10967,8 +11057,8 @@
         </p:nvSpPr>
         <p:spPr>
           <a:xfrm>
-            <a:off x="6400800" y="4937760"/>
-            <a:ext cx="5349240" cy="320040"/>
+            <a:off x="6172200" y="4366260"/>
+            <a:ext cx="5513832" cy="320040"/>
           </a:xfrm>
           <a:prstGeom prst="rect">
             <a:avLst/>
@@ -11002,8 +11092,8 @@
         </p:nvSpPr>
         <p:spPr>
           <a:xfrm>
-            <a:off x="6400800" y="5257800"/>
-            <a:ext cx="5349240" cy="320040"/>
+            <a:off x="6172200" y="4754880"/>
+            <a:ext cx="5513832" cy="320040"/>
           </a:xfrm>
           <a:prstGeom prst="rect">
             <a:avLst/>
@@ -11037,8 +11127,8 @@
         </p:nvSpPr>
         <p:spPr>
           <a:xfrm>
-            <a:off x="6400800" y="5596128"/>
-            <a:ext cx="5349240" cy="320040"/>
+            <a:off x="6172200" y="5120640"/>
+            <a:ext cx="5513832" cy="320040"/>
           </a:xfrm>
           <a:prstGeom prst="rect">
             <a:avLst/>
@@ -11072,8 +11162,8 @@
         </p:nvSpPr>
         <p:spPr>
           <a:xfrm>
-            <a:off x="6400800" y="5934456"/>
-            <a:ext cx="5349240" cy="320040"/>
+            <a:off x="6172200" y="5486400"/>
+            <a:ext cx="5513832" cy="320040"/>
           </a:xfrm>
           <a:prstGeom prst="rect">
             <a:avLst/>
@@ -11107,8 +11197,8 @@
         </p:nvSpPr>
         <p:spPr>
           <a:xfrm>
-            <a:off x="6400800" y="6272783"/>
-            <a:ext cx="5349240" cy="320040"/>
+            <a:off x="6172200" y="5852160"/>
+            <a:ext cx="5513832" cy="320040"/>
           </a:xfrm>
           <a:prstGeom prst="rect">
             <a:avLst/>
@@ -11213,7 +11303,7 @@
 </file>
 
 <file path=ppt/slides/slide7.xml><?xml version="1.0" encoding="utf-8"?>
-<p:sld xmlns:a="http://schemas.openxmlformats.org/drawingml/2006/main" xmlns:p="http://schemas.openxmlformats.org/presentationml/2006/main" xmlns:r="http://schemas.openxmlformats.org/officeDocument/2006/relationships">
+<p:sld xmlns:a="http://schemas.openxmlformats.org/drawingml/2006/main" xmlns:r="http://schemas.openxmlformats.org/officeDocument/2006/relationships" xmlns:p="http://schemas.openxmlformats.org/presentationml/2006/main">
   <p:cSld>
     <p:bg>
       <p:bgPr>
@@ -11229,7 +11319,14 @@
         <p:cNvGrpSpPr/>
         <p:nvPr/>
       </p:nvGrpSpPr>
-      <p:grpSpPr/>
+      <p:grpSpPr>
+        <a:xfrm>
+          <a:off x="0" y="0"/>
+          <a:ext cx="0" cy="0"/>
+          <a:chOff x="0" y="0"/>
+          <a:chExt cx="0" cy="0"/>
+        </a:xfrm>
+      </p:grpSpPr>
       <p:sp>
         <p:nvSpPr>
           <p:cNvPr id="2" name="Rectangle 1"/>
@@ -11270,6 +11367,7 @@
           <a:lstStyle/>
           <a:p>
             <a:pPr algn="ctr"/>
+            <a:endParaRPr/>
           </a:p>
         </p:txBody>
       </p:sp>
@@ -11383,6 +11481,7 @@
           <a:lstStyle/>
           <a:p>
             <a:pPr algn="ctr"/>
+            <a:endParaRPr/>
           </a:p>
         </p:txBody>
       </p:sp>
@@ -11426,6 +11525,7 @@
           <a:lstStyle/>
           <a:p>
             <a:pPr algn="ctr"/>
+            <a:endParaRPr/>
           </a:p>
         </p:txBody>
       </p:sp>
@@ -11469,6 +11569,7 @@
           <a:lstStyle/>
           <a:p>
             <a:pPr algn="ctr"/>
+            <a:endParaRPr/>
           </a:p>
         </p:txBody>
       </p:sp>
@@ -11594,6 +11695,7 @@
           <a:lstStyle/>
           <a:p>
             <a:pPr algn="ctr"/>
+            <a:endParaRPr/>
           </a:p>
         </p:txBody>
       </p:sp>
@@ -11637,6 +11739,7 @@
           <a:lstStyle/>
           <a:p>
             <a:pPr algn="ctr"/>
+            <a:endParaRPr/>
           </a:p>
         </p:txBody>
       </p:sp>
@@ -11762,6 +11865,7 @@
           <a:lstStyle/>
           <a:p>
             <a:pPr algn="ctr"/>
+            <a:endParaRPr/>
           </a:p>
         </p:txBody>
       </p:sp>
@@ -11805,6 +11909,7 @@
           <a:lstStyle/>
           <a:p>
             <a:pPr algn="ctr"/>
+            <a:endParaRPr/>
           </a:p>
         </p:txBody>
       </p:sp>
@@ -11930,6 +12035,7 @@
           <a:lstStyle/>
           <a:p>
             <a:pPr algn="ctr"/>
+            <a:endParaRPr/>
           </a:p>
         </p:txBody>
       </p:sp>
@@ -11975,6 +12081,7 @@
           <a:lstStyle/>
           <a:p>
             <a:pPr algn="ctr"/>
+            <a:endParaRPr/>
           </a:p>
         </p:txBody>
       </p:sp>
@@ -12055,6 +12162,7 @@
           <a:lstStyle/>
           <a:p>
             <a:pPr algn="ctr"/>
+            <a:endParaRPr/>
           </a:p>
         </p:txBody>
       </p:sp>
@@ -12135,6 +12243,7 @@
           <a:lstStyle/>
           <a:p>
             <a:pPr algn="ctr"/>
+            <a:endParaRPr/>
           </a:p>
         </p:txBody>
       </p:sp>
@@ -12213,6 +12322,7 @@
           <a:lstStyle/>
           <a:p>
             <a:pPr algn="ctr"/>
+            <a:endParaRPr/>
           </a:p>
         </p:txBody>
       </p:sp>
@@ -12302,8 +12412,8 @@
         </p:blipFill>
         <p:spPr>
           <a:xfrm>
-            <a:off x="6080760" y="1051560"/>
-            <a:ext cx="5943600" cy="5623560"/>
+            <a:off x="6240780" y="1051560"/>
+            <a:ext cx="5623560" cy="5623560"/>
           </a:xfrm>
           <a:prstGeom prst="rect">
             <a:avLst/>
@@ -12389,7 +12499,7 @@
 </file>
 
 <file path=ppt/slides/slide8.xml><?xml version="1.0" encoding="utf-8"?>
-<p:sld xmlns:a="http://schemas.openxmlformats.org/drawingml/2006/main" xmlns:p="http://schemas.openxmlformats.org/presentationml/2006/main" xmlns:r="http://schemas.openxmlformats.org/officeDocument/2006/relationships">
+<p:sld xmlns:a="http://schemas.openxmlformats.org/drawingml/2006/main" xmlns:r="http://schemas.openxmlformats.org/officeDocument/2006/relationships" xmlns:p="http://schemas.openxmlformats.org/presentationml/2006/main">
   <p:cSld>
     <p:bg>
       <p:bgPr>
@@ -12405,7 +12515,14 @@
         <p:cNvGrpSpPr/>
         <p:nvPr/>
       </p:nvGrpSpPr>
-      <p:grpSpPr/>
+      <p:grpSpPr>
+        <a:xfrm>
+          <a:off x="0" y="0"/>
+          <a:ext cx="0" cy="0"/>
+          <a:chOff x="0" y="0"/>
+          <a:chExt cx="0" cy="0"/>
+        </a:xfrm>
+      </p:grpSpPr>
       <p:sp>
         <p:nvSpPr>
           <p:cNvPr id="2" name="Rectangle 1"/>
@@ -12446,6 +12563,7 @@
           <a:lstStyle/>
           <a:p>
             <a:pPr algn="ctr"/>
+            <a:endParaRPr/>
           </a:p>
         </p:txBody>
       </p:sp>
@@ -12524,6 +12642,7 @@
           <a:lstStyle/>
           <a:p>
             <a:pPr algn="ctr"/>
+            <a:endParaRPr/>
           </a:p>
         </p:txBody>
       </p:sp>
@@ -12567,6 +12686,7 @@
           <a:lstStyle/>
           <a:p>
             <a:pPr algn="ctr"/>
+            <a:endParaRPr/>
           </a:p>
         </p:txBody>
       </p:sp>
@@ -12692,6 +12812,7 @@
           <a:lstStyle/>
           <a:p>
             <a:pPr algn="ctr"/>
+            <a:endParaRPr/>
           </a:p>
         </p:txBody>
       </p:sp>
@@ -12770,6 +12891,7 @@
           <a:lstStyle/>
           <a:p>
             <a:pPr algn="ctr"/>
+            <a:endParaRPr/>
           </a:p>
         </p:txBody>
       </p:sp>
@@ -12813,6 +12935,7 @@
           <a:lstStyle/>
           <a:p>
             <a:pPr algn="ctr"/>
+            <a:endParaRPr/>
           </a:p>
         </p:txBody>
       </p:sp>
@@ -12938,6 +13061,7 @@
           <a:lstStyle/>
           <a:p>
             <a:pPr algn="ctr"/>
+            <a:endParaRPr/>
           </a:p>
         </p:txBody>
       </p:sp>
@@ -13016,6 +13140,7 @@
           <a:lstStyle/>
           <a:p>
             <a:pPr algn="ctr"/>
+            <a:endParaRPr/>
           </a:p>
         </p:txBody>
       </p:sp>
@@ -13059,6 +13184,7 @@
           <a:lstStyle/>
           <a:p>
             <a:pPr algn="ctr"/>
+            <a:endParaRPr/>
           </a:p>
         </p:txBody>
       </p:sp>
@@ -13184,6 +13310,7 @@
           <a:lstStyle/>
           <a:p>
             <a:pPr algn="ctr"/>
+            <a:endParaRPr/>
           </a:p>
         </p:txBody>
       </p:sp>
@@ -13262,6 +13389,7 @@
           <a:lstStyle/>
           <a:p>
             <a:pPr algn="ctr"/>
+            <a:endParaRPr/>
           </a:p>
         </p:txBody>
       </p:sp>
@@ -13305,6 +13433,7 @@
           <a:lstStyle/>
           <a:p>
             <a:pPr algn="ctr"/>
+            <a:endParaRPr/>
           </a:p>
         </p:txBody>
       </p:sp>
@@ -13430,6 +13559,7 @@
           <a:lstStyle/>
           <a:p>
             <a:pPr algn="ctr"/>
+            <a:endParaRPr/>
           </a:p>
         </p:txBody>
       </p:sp>
@@ -13547,7 +13677,7 @@
 </file>
 
 <file path=ppt/slides/slide9.xml><?xml version="1.0" encoding="utf-8"?>
-<p:sld xmlns:a="http://schemas.openxmlformats.org/drawingml/2006/main" xmlns:p="http://schemas.openxmlformats.org/presentationml/2006/main" xmlns:r="http://schemas.openxmlformats.org/officeDocument/2006/relationships">
+<p:sld xmlns:a="http://schemas.openxmlformats.org/drawingml/2006/main" xmlns:r="http://schemas.openxmlformats.org/officeDocument/2006/relationships" xmlns:p="http://schemas.openxmlformats.org/presentationml/2006/main">
   <p:cSld>
     <p:bg>
       <p:bgPr>
@@ -13563,7 +13693,14 @@
         <p:cNvGrpSpPr/>
         <p:nvPr/>
       </p:nvGrpSpPr>
-      <p:grpSpPr/>
+      <p:grpSpPr>
+        <a:xfrm>
+          <a:off x="0" y="0"/>
+          <a:ext cx="0" cy="0"/>
+          <a:chOff x="0" y="0"/>
+          <a:chExt cx="0" cy="0"/>
+        </a:xfrm>
+      </p:grpSpPr>
       <p:sp>
         <p:nvSpPr>
           <p:cNvPr id="2" name="Rectangle 1"/>
@@ -13604,6 +13741,7 @@
           <a:lstStyle/>
           <a:p>
             <a:pPr algn="ctr"/>
+            <a:endParaRPr/>
           </a:p>
         </p:txBody>
       </p:sp>
@@ -13647,6 +13785,7 @@
           <a:lstStyle/>
           <a:p>
             <a:pPr algn="ctr"/>
+            <a:endParaRPr/>
           </a:p>
         </p:txBody>
       </p:sp>
@@ -13725,6 +13864,7 @@
           <a:lstStyle/>
           <a:p>
             <a:pPr algn="ctr"/>
+            <a:endParaRPr/>
           </a:p>
         </p:txBody>
       </p:sp>
@@ -13768,6 +13908,7 @@
           <a:lstStyle/>
           <a:p>
             <a:pPr algn="ctr"/>
+            <a:endParaRPr/>
           </a:p>
         </p:txBody>
       </p:sp>
@@ -13811,6 +13952,7 @@
           <a:lstStyle/>
           <a:p>
             <a:pPr algn="ctr"/>
+            <a:endParaRPr/>
           </a:p>
         </p:txBody>
       </p:sp>
@@ -13961,6 +14103,7 @@
           <a:lstStyle/>
           <a:p>
             <a:pPr algn="ctr"/>
+            <a:endParaRPr/>
           </a:p>
         </p:txBody>
       </p:sp>
@@ -14039,6 +14182,7 @@
           <a:lstStyle/>
           <a:p>
             <a:pPr algn="ctr"/>
+            <a:endParaRPr/>
           </a:p>
         </p:txBody>
       </p:sp>
@@ -14082,6 +14226,7 @@
           <a:lstStyle/>
           <a:p>
             <a:pPr algn="ctr"/>
+            <a:endParaRPr/>
           </a:p>
         </p:txBody>
       </p:sp>
@@ -14125,6 +14270,7 @@
           <a:lstStyle/>
           <a:p>
             <a:pPr algn="ctr"/>
+            <a:endParaRPr/>
           </a:p>
         </p:txBody>
       </p:sp>
@@ -14275,6 +14421,7 @@
           <a:lstStyle/>
           <a:p>
             <a:pPr algn="ctr"/>
+            <a:endParaRPr/>
           </a:p>
         </p:txBody>
       </p:sp>
@@ -14353,6 +14500,7 @@
           <a:lstStyle/>
           <a:p>
             <a:pPr algn="ctr"/>
+            <a:endParaRPr/>
           </a:p>
         </p:txBody>
       </p:sp>
@@ -14396,6 +14544,7 @@
           <a:lstStyle/>
           <a:p>
             <a:pPr algn="ctr"/>
+            <a:endParaRPr/>
           </a:p>
         </p:txBody>
       </p:sp>
@@ -14439,6 +14588,7 @@
           <a:lstStyle/>
           <a:p>
             <a:pPr algn="ctr"/>
+            <a:endParaRPr/>
           </a:p>
         </p:txBody>
       </p:sp>
@@ -14589,6 +14739,7 @@
           <a:lstStyle/>
           <a:p>
             <a:pPr algn="ctr"/>
+            <a:endParaRPr/>
           </a:p>
         </p:txBody>
       </p:sp>
@@ -14667,6 +14818,7 @@
           <a:lstStyle/>
           <a:p>
             <a:pPr algn="ctr"/>
+            <a:endParaRPr/>
           </a:p>
         </p:txBody>
       </p:sp>
@@ -14710,6 +14862,7 @@
           <a:lstStyle/>
           <a:p>
             <a:pPr algn="ctr"/>
+            <a:endParaRPr/>
           </a:p>
         </p:txBody>
       </p:sp>
@@ -14753,6 +14906,7 @@
           <a:lstStyle/>
           <a:p>
             <a:pPr algn="ctr"/>
+            <a:endParaRPr/>
           </a:p>
         </p:txBody>
       </p:sp>
@@ -14903,6 +15057,7 @@
           <a:lstStyle/>
           <a:p>
             <a:pPr algn="ctr"/>
+            <a:endParaRPr/>
           </a:p>
         </p:txBody>
       </p:sp>
@@ -15337,4 +15492,10 @@
   </a:objectDefaults>
   <a:extraClrSchemeLst/>
 </a:theme>
+</file>
+
+<file path=docMetadata/LabelInfo.xml><?xml version="1.0" encoding="utf-8"?>
+<clbl:labelList xmlns:clbl="http://schemas.microsoft.com/office/2020/mipLabelMetadata">
+  <clbl:label id="{ff6dbec8-95a8-4638-9f5f-bd076536645c}" enabled="1" method="Standard" siteId="{5dbf1add-202a-4b8d-815b-bf0fb024e033}" contentBits="0" removed="0"/>
+</clbl:labelList>
 </file>
</xml_diff>